<commit_message>
fix(documents): share checked OOXML projection and table invariants
</commit_message>
<xml_diff>
--- a/zig/pkg/inference/src/documents/testdata/inherited-slides.pptx
+++ b/zig/pkg/inference/src/documents/testdata/inherited-slides.pptx
@@ -1,6 +1,6 @@
 
 <file path=ppt/presentation.xml><?xml version="1.0" encoding="utf-8"?>
-<p:presentation xmlns:p="p" xmlns:r="r">
+<p:presentation xmlns:p="http://schemas.openxmlformats.org/presentationml/2006/main" xmlns:r="http://schemas.openxmlformats.org/officeDocument/2006/relationships">
   <p:sldIdLst>
     <p:sldId id="1" r:id="second"/>
     <p:sldId id="2" r:id="first"/>
@@ -9,12 +9,12 @@
 </file>
 
 <file path=ppt/slideLayouts/slideLayout1.xml><?xml version="1.0" encoding="utf-8"?>
-<p:sldLayout xmlns:p="p">
+<p:sldLayout xmlns:a="http://schemas.openxmlformats.org/drawingml/2006/main" xmlns:p="http://schemas.openxmlformats.org/presentationml/2006/main">
   <p:cSld>
     <p:spTree>
       <p:sp>
         <p:ph/>
-        <a:t xmlns:a="a">Template title</a:t>
+        <a:t>Template title</a:t>
       </p:sp>
     </p:spTree>
   </p:cSld>
@@ -22,7 +22,7 @@
 </file>
 
 <file path=ppt/slideMasters/slideMaster1.xml><?xml version="1.0" encoding="utf-8"?>
-<p:sldMaster xmlns:p="p" xmlns:a="a">
+<p:sldMaster xmlns:a="http://schemas.openxmlformats.org/drawingml/2006/main" xmlns:p="http://schemas.openxmlformats.org/presentationml/2006/main">
   <p:cSld>
     <p:spTree>
       <p:pic>
@@ -30,11 +30,17 @@
       </p:pic>
       <p:sp>
         <p:txBody>
-          <a:p>
-            <a:r>
-              <a:t>Confidential</a:t>
-            </a:r>
-          </a:p>
+          <p:sp>
+            <p:txBody>
+              <a:bodyPr/>
+              <a:lstStyle/>
+              <a:p>
+                <a:r>
+                  <a:t>Confidential</a:t>
+                </a:r>
+              </a:p>
+            </p:txBody>
+          </p:sp>
         </p:txBody>
       </p:sp>
       <p:sp>
@@ -47,21 +53,33 @@
 </file>
 
 <file path=ppt/slides/slide1.xml><?xml version="1.0" encoding="utf-8"?>
-<p:sld xmlns:p="p" xmlns:a="a" showMasterSp="false">
-  <a:p>
-    <a:r>
-      <a:t>Slide 1</a:t>
-    </a:r>
-  </a:p>
+<p:sld xmlns:a="http://schemas.openxmlformats.org/drawingml/2006/main" xmlns:p="http://schemas.openxmlformats.org/presentationml/2006/main" showMasterSp="false">
+  <p:sp>
+    <p:txBody>
+      <a:bodyPr/>
+      <a:lstStyle/>
+      <a:p>
+        <a:r>
+          <a:t>Slide 1</a:t>
+        </a:r>
+      </a:p>
+    </p:txBody>
+  </p:sp>
 </p:sld>
 </file>
 
 <file path=ppt/slides/slide2.xml><?xml version="1.0" encoding="utf-8"?>
-<p:sld xmlns:p="p" xmlns:a="a">
-  <a:p>
-    <a:r>
-      <a:t>Slide 2</a:t>
-    </a:r>
-  </a:p>
+<p:sld xmlns:a="http://schemas.openxmlformats.org/drawingml/2006/main" xmlns:p="http://schemas.openxmlformats.org/presentationml/2006/main">
+  <p:sp>
+    <p:txBody>
+      <a:bodyPr/>
+      <a:lstStyle/>
+      <a:p>
+        <a:r>
+          <a:t>Slide 2</a:t>
+        </a:r>
+      </a:p>
+    </p:txBody>
+  </p:sp>
 </p:sld>
 </file>
</xml_diff>